<commit_message>
feat(presentation): add all 4 model tiers for hosting environments
- Update technical specs slide with complete model registry from config.yaml
- Tier 1 (Laptop): Parasail A1(2.5)-VL-3B via Ollama, 6 GB VRAM
- Tier 2 (Reference): Qwen2.5-VL-7B-AWQ via vLLM, 12 GB VRAM
- Tier 3 (Local 7B): Qwen2.5-VL-7B via Ollama, 10 GB VRAM
- Tier 4 (Datacenter): Qwen2.5-VL-72B-AWQ via vLLM, 48 GB VRAM
- Each tier shows label, model ID, backend, VRAM, download size, and use case
</commit_message>
<xml_diff>
--- a/ParaSail_Data_Sources_API_Architecture.pptx
+++ b/ParaSail_Data_Sources_API_Architecture.pptx
@@ -4564,7 +4564,7 @@
                 <a:gridCol w="2743200"/>
                 <a:gridCol w="6675120"/>
               </a:tblGrid>
-              <a:tr h="230588">
+              <a:tr h="196427">
                 <a:tc>
                   <a:txBody>
                     <a:bodyPr/>
@@ -4761,7 +4761,7 @@
                   </a:tcPr>
                 </a:tc>
               </a:tr>
-              <a:tr h="230588">
+              <a:tr h="196427">
                 <a:tc>
                   <a:txBody>
                     <a:bodyPr/>
@@ -4958,7 +4958,7 @@
                   </a:tcPr>
                 </a:tc>
               </a:tr>
-              <a:tr h="230588">
+              <a:tr h="196427">
                 <a:tc>
                   <a:txBody>
                     <a:bodyPr/>
@@ -5155,7 +5155,7 @@
                   </a:tcPr>
                 </a:tc>
               </a:tr>
-              <a:tr h="230588">
+              <a:tr h="196427">
                 <a:tc>
                   <a:txBody>
                     <a:bodyPr/>
@@ -5352,7 +5352,7 @@
                   </a:tcPr>
                 </a:tc>
               </a:tr>
-              <a:tr h="230588">
+              <a:tr h="196427">
                 <a:tc>
                   <a:txBody>
                     <a:bodyPr/>
@@ -5549,7 +5549,7 @@
                   </a:tcPr>
                 </a:tc>
               </a:tr>
-              <a:tr h="230588">
+              <a:tr h="196427">
                 <a:tc>
                   <a:txBody>
                     <a:bodyPr/>
@@ -5746,7 +5746,7 @@
                   </a:tcPr>
                 </a:tc>
               </a:tr>
-              <a:tr h="230588">
+              <a:tr h="196427">
                 <a:tc>
                   <a:txBody>
                     <a:bodyPr/>
@@ -5943,7 +5943,7 @@
                   </a:tcPr>
                 </a:tc>
               </a:tr>
-              <a:tr h="230588">
+              <a:tr h="196427">
                 <a:tc>
                   <a:txBody>
                     <a:bodyPr/>
@@ -6140,7 +6140,7 @@
                   </a:tcPr>
                 </a:tc>
               </a:tr>
-              <a:tr h="230588">
+              <a:tr h="196427">
                 <a:tc>
                   <a:txBody>
                     <a:bodyPr/>
@@ -6337,7 +6337,7 @@
                   </a:tcPr>
                 </a:tc>
               </a:tr>
-              <a:tr h="230588">
+              <a:tr h="196427">
                 <a:tc>
                   <a:txBody>
                     <a:bodyPr/>
@@ -6534,7 +6534,7 @@
                   </a:tcPr>
                 </a:tc>
               </a:tr>
-              <a:tr h="230588">
+              <a:tr h="196427">
                 <a:tc>
                   <a:txBody>
                     <a:bodyPr/>
@@ -6731,7 +6731,7 @@
                   </a:tcPr>
                 </a:tc>
               </a:tr>
-              <a:tr h="230588">
+              <a:tr h="196427">
                 <a:tc>
                   <a:txBody>
                     <a:bodyPr/>
@@ -6928,7 +6928,795 @@
                   </a:tcPr>
                 </a:tc>
               </a:tr>
-              <a:tr h="230588">
+              <a:tr h="196427">
+                <a:tc>
+                  <a:txBody>
+                    <a:bodyPr/>
+                    <a:lstStyle/>
+                    <a:p>
+                      <a:pPr indent="0" marL="0">
+                        <a:buNone/>
+                      </a:pPr>
+                      <a:r>
+                        <a:rPr lang="en-US" sz="1000" dirty="0">
+                          <a:solidFill>
+                            <a:srgbClr val="1E293B"/>
+                          </a:solidFill>
+                          <a:latin typeface="Inter" pitchFamily="34" charset="0"/>
+                          <a:ea typeface="Inter" pitchFamily="34" charset="-122"/>
+                          <a:cs typeface="Inter" pitchFamily="34" charset="-120"/>
+                        </a:rPr>
+                        <a:t>AI Model</a:t>
+                      </a:r>
+                      <a:endParaRPr lang="en-US" sz="1000" dirty="0">
+                        <a:latin typeface="Inter" charset="0"/>
+                        <a:ea typeface="Inter" charset="0"/>
+                        <a:cs typeface="Inter" charset="0"/>
+                      </a:endParaRPr>
+                    </a:p>
+                  </a:txBody>
+                  <a:tcPr marL="91440" marR="91440" marT="45720" marB="45720">
+                    <a:lnL w="6350" cap="flat" cmpd="sng" algn="ctr">
+                      <a:solidFill>
+                        <a:srgbClr val="E2E8F0"/>
+                      </a:solidFill>
+                      <a:prstDash val="solid"/>
+                      <a:round/>
+                      <a:headEnd type="none" w="med" len="med"/>
+                      <a:tailEnd type="none" w="med" len="med"/>
+                    </a:lnL>
+                    <a:lnR w="6350" cap="flat" cmpd="sng" algn="ctr">
+                      <a:solidFill>
+                        <a:srgbClr val="E2E8F0"/>
+                      </a:solidFill>
+                      <a:prstDash val="solid"/>
+                      <a:round/>
+                      <a:headEnd type="none" w="med" len="med"/>
+                      <a:tailEnd type="none" w="med" len="med"/>
+                    </a:lnR>
+                    <a:lnT w="6350" cap="flat" cmpd="sng" algn="ctr">
+                      <a:solidFill>
+                        <a:srgbClr val="E2E8F0"/>
+                      </a:solidFill>
+                      <a:prstDash val="solid"/>
+                      <a:round/>
+                      <a:headEnd type="none" w="med" len="med"/>
+                      <a:tailEnd type="none" w="med" len="med"/>
+                    </a:lnT>
+                    <a:lnB w="6350" cap="flat" cmpd="sng" algn="ctr">
+                      <a:solidFill>
+                        <a:srgbClr val="E2E8F0"/>
+                      </a:solidFill>
+                      <a:prstDash val="solid"/>
+                      <a:round/>
+                      <a:headEnd type="none" w="med" len="med"/>
+                      <a:tailEnd type="none" w="med" len="med"/>
+                    </a:lnB>
+                  </a:tcPr>
+                </a:tc>
+                <a:tc>
+                  <a:txBody>
+                    <a:bodyPr/>
+                    <a:lstStyle/>
+                    <a:p>
+                      <a:pPr indent="0" marL="0">
+                        <a:buNone/>
+                      </a:pPr>
+                      <a:r>
+                        <a:rPr lang="en-US" sz="1000" dirty="0">
+                          <a:solidFill>
+                            <a:srgbClr val="1E293B"/>
+                          </a:solidFill>
+                          <a:latin typeface="Inter" pitchFamily="34" charset="0"/>
+                          <a:ea typeface="Inter" pitchFamily="34" charset="-122"/>
+                          <a:cs typeface="Inter" pitchFamily="34" charset="-120"/>
+                        </a:rPr>
+                        <a:t>Tier 1 — Laptop</a:t>
+                      </a:r>
+                      <a:endParaRPr lang="en-US" sz="1000" dirty="0">
+                        <a:latin typeface="Inter" charset="0"/>
+                        <a:ea typeface="Inter" charset="0"/>
+                        <a:cs typeface="Inter" charset="0"/>
+                      </a:endParaRPr>
+                    </a:p>
+                  </a:txBody>
+                  <a:tcPr marL="91440" marR="91440" marT="45720" marB="45720">
+                    <a:lnL w="6350" cap="flat" cmpd="sng" algn="ctr">
+                      <a:solidFill>
+                        <a:srgbClr val="E2E8F0"/>
+                      </a:solidFill>
+                      <a:prstDash val="solid"/>
+                      <a:round/>
+                      <a:headEnd type="none" w="med" len="med"/>
+                      <a:tailEnd type="none" w="med" len="med"/>
+                    </a:lnL>
+                    <a:lnR w="6350" cap="flat" cmpd="sng" algn="ctr">
+                      <a:solidFill>
+                        <a:srgbClr val="E2E8F0"/>
+                      </a:solidFill>
+                      <a:prstDash val="solid"/>
+                      <a:round/>
+                      <a:headEnd type="none" w="med" len="med"/>
+                      <a:tailEnd type="none" w="med" len="med"/>
+                    </a:lnR>
+                    <a:lnT w="6350" cap="flat" cmpd="sng" algn="ctr">
+                      <a:solidFill>
+                        <a:srgbClr val="E2E8F0"/>
+                      </a:solidFill>
+                      <a:prstDash val="solid"/>
+                      <a:round/>
+                      <a:headEnd type="none" w="med" len="med"/>
+                      <a:tailEnd type="none" w="med" len="med"/>
+                    </a:lnT>
+                    <a:lnB w="6350" cap="flat" cmpd="sng" algn="ctr">
+                      <a:solidFill>
+                        <a:srgbClr val="E2E8F0"/>
+                      </a:solidFill>
+                      <a:prstDash val="solid"/>
+                      <a:round/>
+                      <a:headEnd type="none" w="med" len="med"/>
+                      <a:tailEnd type="none" w="med" len="med"/>
+                    </a:lnB>
+                  </a:tcPr>
+                </a:tc>
+                <a:tc>
+                  <a:txBody>
+                    <a:bodyPr/>
+                    <a:lstStyle/>
+                    <a:p>
+                      <a:pPr indent="0" marL="0">
+                        <a:buNone/>
+                      </a:pPr>
+                      <a:r>
+                        <a:rPr lang="en-US" sz="1000" dirty="0">
+                          <a:solidFill>
+                            <a:srgbClr val="1E293B"/>
+                          </a:solidFill>
+                          <a:latin typeface="Inter" pitchFamily="34" charset="0"/>
+                          <a:ea typeface="Inter" pitchFamily="34" charset="-122"/>
+                          <a:cs typeface="Inter" pitchFamily="34" charset="-120"/>
+                        </a:rPr>
+                        <a:t>Parasail A1(2.5)-VL-3B | qwen2.5vl:3b | Ollama | 6 GB VRAM | 2.5 GB DL | Fastest</a:t>
+                      </a:r>
+                      <a:endParaRPr lang="en-US" sz="1000" dirty="0">
+                        <a:latin typeface="Inter" charset="0"/>
+                        <a:ea typeface="Inter" charset="0"/>
+                        <a:cs typeface="Inter" charset="0"/>
+                      </a:endParaRPr>
+                    </a:p>
+                  </a:txBody>
+                  <a:tcPr marL="91440" marR="91440" marT="45720" marB="45720">
+                    <a:lnL w="6350" cap="flat" cmpd="sng" algn="ctr">
+                      <a:solidFill>
+                        <a:srgbClr val="E2E8F0"/>
+                      </a:solidFill>
+                      <a:prstDash val="solid"/>
+                      <a:round/>
+                      <a:headEnd type="none" w="med" len="med"/>
+                      <a:tailEnd type="none" w="med" len="med"/>
+                    </a:lnL>
+                    <a:lnR w="6350" cap="flat" cmpd="sng" algn="ctr">
+                      <a:solidFill>
+                        <a:srgbClr val="E2E8F0"/>
+                      </a:solidFill>
+                      <a:prstDash val="solid"/>
+                      <a:round/>
+                      <a:headEnd type="none" w="med" len="med"/>
+                      <a:tailEnd type="none" w="med" len="med"/>
+                    </a:lnR>
+                    <a:lnT w="6350" cap="flat" cmpd="sng" algn="ctr">
+                      <a:solidFill>
+                        <a:srgbClr val="E2E8F0"/>
+                      </a:solidFill>
+                      <a:prstDash val="solid"/>
+                      <a:round/>
+                      <a:headEnd type="none" w="med" len="med"/>
+                      <a:tailEnd type="none" w="med" len="med"/>
+                    </a:lnT>
+                    <a:lnB w="6350" cap="flat" cmpd="sng" algn="ctr">
+                      <a:solidFill>
+                        <a:srgbClr val="E2E8F0"/>
+                      </a:solidFill>
+                      <a:prstDash val="solid"/>
+                      <a:round/>
+                      <a:headEnd type="none" w="med" len="med"/>
+                      <a:tailEnd type="none" w="med" len="med"/>
+                    </a:lnB>
+                  </a:tcPr>
+                </a:tc>
+              </a:tr>
+              <a:tr h="196427">
+                <a:tc>
+                  <a:txBody>
+                    <a:bodyPr/>
+                    <a:lstStyle/>
+                    <a:p>
+                      <a:pPr indent="0" marL="0">
+                        <a:buNone/>
+                      </a:pPr>
+                      <a:r>
+                        <a:rPr lang="en-US" sz="1000" dirty="0">
+                          <a:solidFill>
+                            <a:srgbClr val="1E293B"/>
+                          </a:solidFill>
+                          <a:latin typeface="Inter" pitchFamily="34" charset="0"/>
+                          <a:ea typeface="Inter" pitchFamily="34" charset="-122"/>
+                          <a:cs typeface="Inter" pitchFamily="34" charset="-120"/>
+                        </a:rPr>
+                        <a:t>AI Model</a:t>
+                      </a:r>
+                      <a:endParaRPr lang="en-US" sz="1000" dirty="0">
+                        <a:latin typeface="Inter" charset="0"/>
+                        <a:ea typeface="Inter" charset="0"/>
+                        <a:cs typeface="Inter" charset="0"/>
+                      </a:endParaRPr>
+                    </a:p>
+                  </a:txBody>
+                  <a:tcPr marL="91440" marR="91440" marT="45720" marB="45720">
+                    <a:lnL w="6350" cap="flat" cmpd="sng" algn="ctr">
+                      <a:solidFill>
+                        <a:srgbClr val="E2E8F0"/>
+                      </a:solidFill>
+                      <a:prstDash val="solid"/>
+                      <a:round/>
+                      <a:headEnd type="none" w="med" len="med"/>
+                      <a:tailEnd type="none" w="med" len="med"/>
+                    </a:lnL>
+                    <a:lnR w="6350" cap="flat" cmpd="sng" algn="ctr">
+                      <a:solidFill>
+                        <a:srgbClr val="E2E8F0"/>
+                      </a:solidFill>
+                      <a:prstDash val="solid"/>
+                      <a:round/>
+                      <a:headEnd type="none" w="med" len="med"/>
+                      <a:tailEnd type="none" w="med" len="med"/>
+                    </a:lnR>
+                    <a:lnT w="6350" cap="flat" cmpd="sng" algn="ctr">
+                      <a:solidFill>
+                        <a:srgbClr val="E2E8F0"/>
+                      </a:solidFill>
+                      <a:prstDash val="solid"/>
+                      <a:round/>
+                      <a:headEnd type="none" w="med" len="med"/>
+                      <a:tailEnd type="none" w="med" len="med"/>
+                    </a:lnT>
+                    <a:lnB w="6350" cap="flat" cmpd="sng" algn="ctr">
+                      <a:solidFill>
+                        <a:srgbClr val="E2E8F0"/>
+                      </a:solidFill>
+                      <a:prstDash val="solid"/>
+                      <a:round/>
+                      <a:headEnd type="none" w="med" len="med"/>
+                      <a:tailEnd type="none" w="med" len="med"/>
+                    </a:lnB>
+                  </a:tcPr>
+                </a:tc>
+                <a:tc>
+                  <a:txBody>
+                    <a:bodyPr/>
+                    <a:lstStyle/>
+                    <a:p>
+                      <a:pPr indent="0" marL="0">
+                        <a:buNone/>
+                      </a:pPr>
+                      <a:r>
+                        <a:rPr lang="en-US" sz="1000" dirty="0">
+                          <a:solidFill>
+                            <a:srgbClr val="1E293B"/>
+                          </a:solidFill>
+                          <a:latin typeface="Inter" pitchFamily="34" charset="0"/>
+                          <a:ea typeface="Inter" pitchFamily="34" charset="-122"/>
+                          <a:cs typeface="Inter" pitchFamily="34" charset="-120"/>
+                        </a:rPr>
+                        <a:t>Tier 2 — Reference</a:t>
+                      </a:r>
+                      <a:endParaRPr lang="en-US" sz="1000" dirty="0">
+                        <a:latin typeface="Inter" charset="0"/>
+                        <a:ea typeface="Inter" charset="0"/>
+                        <a:cs typeface="Inter" charset="0"/>
+                      </a:endParaRPr>
+                    </a:p>
+                  </a:txBody>
+                  <a:tcPr marL="91440" marR="91440" marT="45720" marB="45720">
+                    <a:lnL w="6350" cap="flat" cmpd="sng" algn="ctr">
+                      <a:solidFill>
+                        <a:srgbClr val="E2E8F0"/>
+                      </a:solidFill>
+                      <a:prstDash val="solid"/>
+                      <a:round/>
+                      <a:headEnd type="none" w="med" len="med"/>
+                      <a:tailEnd type="none" w="med" len="med"/>
+                    </a:lnL>
+                    <a:lnR w="6350" cap="flat" cmpd="sng" algn="ctr">
+                      <a:solidFill>
+                        <a:srgbClr val="E2E8F0"/>
+                      </a:solidFill>
+                      <a:prstDash val="solid"/>
+                      <a:round/>
+                      <a:headEnd type="none" w="med" len="med"/>
+                      <a:tailEnd type="none" w="med" len="med"/>
+                    </a:lnR>
+                    <a:lnT w="6350" cap="flat" cmpd="sng" algn="ctr">
+                      <a:solidFill>
+                        <a:srgbClr val="E2E8F0"/>
+                      </a:solidFill>
+                      <a:prstDash val="solid"/>
+                      <a:round/>
+                      <a:headEnd type="none" w="med" len="med"/>
+                      <a:tailEnd type="none" w="med" len="med"/>
+                    </a:lnT>
+                    <a:lnB w="6350" cap="flat" cmpd="sng" algn="ctr">
+                      <a:solidFill>
+                        <a:srgbClr val="E2E8F0"/>
+                      </a:solidFill>
+                      <a:prstDash val="solid"/>
+                      <a:round/>
+                      <a:headEnd type="none" w="med" len="med"/>
+                      <a:tailEnd type="none" w="med" len="med"/>
+                    </a:lnB>
+                  </a:tcPr>
+                </a:tc>
+                <a:tc>
+                  <a:txBody>
+                    <a:bodyPr/>
+                    <a:lstStyle/>
+                    <a:p>
+                      <a:pPr indent="0" marL="0">
+                        <a:buNone/>
+                      </a:pPr>
+                      <a:r>
+                        <a:rPr lang="en-US" sz="1000" dirty="0">
+                          <a:solidFill>
+                            <a:srgbClr val="1E293B"/>
+                          </a:solidFill>
+                          <a:latin typeface="Inter" pitchFamily="34" charset="0"/>
+                          <a:ea typeface="Inter" pitchFamily="34" charset="-122"/>
+                          <a:cs typeface="Inter" pitchFamily="34" charset="-120"/>
+                        </a:rPr>
+                        <a:t>Qwen2.5-VL-7B-AWQ | Qwen/Qwen2.5-VL-7B-Instruct-AWQ | vLLM | 12 GB VRAM | 6.9 GB DL | Best quality</a:t>
+                      </a:r>
+                      <a:endParaRPr lang="en-US" sz="1000" dirty="0">
+                        <a:latin typeface="Inter" charset="0"/>
+                        <a:ea typeface="Inter" charset="0"/>
+                        <a:cs typeface="Inter" charset="0"/>
+                      </a:endParaRPr>
+                    </a:p>
+                  </a:txBody>
+                  <a:tcPr marL="91440" marR="91440" marT="45720" marB="45720">
+                    <a:lnL w="6350" cap="flat" cmpd="sng" algn="ctr">
+                      <a:solidFill>
+                        <a:srgbClr val="E2E8F0"/>
+                      </a:solidFill>
+                      <a:prstDash val="solid"/>
+                      <a:round/>
+                      <a:headEnd type="none" w="med" len="med"/>
+                      <a:tailEnd type="none" w="med" len="med"/>
+                    </a:lnL>
+                    <a:lnR w="6350" cap="flat" cmpd="sng" algn="ctr">
+                      <a:solidFill>
+                        <a:srgbClr val="E2E8F0"/>
+                      </a:solidFill>
+                      <a:prstDash val="solid"/>
+                      <a:round/>
+                      <a:headEnd type="none" w="med" len="med"/>
+                      <a:tailEnd type="none" w="med" len="med"/>
+                    </a:lnR>
+                    <a:lnT w="6350" cap="flat" cmpd="sng" algn="ctr">
+                      <a:solidFill>
+                        <a:srgbClr val="E2E8F0"/>
+                      </a:solidFill>
+                      <a:prstDash val="solid"/>
+                      <a:round/>
+                      <a:headEnd type="none" w="med" len="med"/>
+                      <a:tailEnd type="none" w="med" len="med"/>
+                    </a:lnT>
+                    <a:lnB w="6350" cap="flat" cmpd="sng" algn="ctr">
+                      <a:solidFill>
+                        <a:srgbClr val="E2E8F0"/>
+                      </a:solidFill>
+                      <a:prstDash val="solid"/>
+                      <a:round/>
+                      <a:headEnd type="none" w="med" len="med"/>
+                      <a:tailEnd type="none" w="med" len="med"/>
+                    </a:lnB>
+                  </a:tcPr>
+                </a:tc>
+              </a:tr>
+              <a:tr h="196427">
+                <a:tc>
+                  <a:txBody>
+                    <a:bodyPr/>
+                    <a:lstStyle/>
+                    <a:p>
+                      <a:pPr indent="0" marL="0">
+                        <a:buNone/>
+                      </a:pPr>
+                      <a:r>
+                        <a:rPr lang="en-US" sz="1000" dirty="0">
+                          <a:solidFill>
+                            <a:srgbClr val="1E293B"/>
+                          </a:solidFill>
+                          <a:latin typeface="Inter" pitchFamily="34" charset="0"/>
+                          <a:ea typeface="Inter" pitchFamily="34" charset="-122"/>
+                          <a:cs typeface="Inter" pitchFamily="34" charset="-120"/>
+                        </a:rPr>
+                        <a:t>AI Model</a:t>
+                      </a:r>
+                      <a:endParaRPr lang="en-US" sz="1000" dirty="0">
+                        <a:latin typeface="Inter" charset="0"/>
+                        <a:ea typeface="Inter" charset="0"/>
+                        <a:cs typeface="Inter" charset="0"/>
+                      </a:endParaRPr>
+                    </a:p>
+                  </a:txBody>
+                  <a:tcPr marL="91440" marR="91440" marT="45720" marB="45720">
+                    <a:lnL w="6350" cap="flat" cmpd="sng" algn="ctr">
+                      <a:solidFill>
+                        <a:srgbClr val="E2E8F0"/>
+                      </a:solidFill>
+                      <a:prstDash val="solid"/>
+                      <a:round/>
+                      <a:headEnd type="none" w="med" len="med"/>
+                      <a:tailEnd type="none" w="med" len="med"/>
+                    </a:lnL>
+                    <a:lnR w="6350" cap="flat" cmpd="sng" algn="ctr">
+                      <a:solidFill>
+                        <a:srgbClr val="E2E8F0"/>
+                      </a:solidFill>
+                      <a:prstDash val="solid"/>
+                      <a:round/>
+                      <a:headEnd type="none" w="med" len="med"/>
+                      <a:tailEnd type="none" w="med" len="med"/>
+                    </a:lnR>
+                    <a:lnT w="6350" cap="flat" cmpd="sng" algn="ctr">
+                      <a:solidFill>
+                        <a:srgbClr val="E2E8F0"/>
+                      </a:solidFill>
+                      <a:prstDash val="solid"/>
+                      <a:round/>
+                      <a:headEnd type="none" w="med" len="med"/>
+                      <a:tailEnd type="none" w="med" len="med"/>
+                    </a:lnT>
+                    <a:lnB w="6350" cap="flat" cmpd="sng" algn="ctr">
+                      <a:solidFill>
+                        <a:srgbClr val="E2E8F0"/>
+                      </a:solidFill>
+                      <a:prstDash val="solid"/>
+                      <a:round/>
+                      <a:headEnd type="none" w="med" len="med"/>
+                      <a:tailEnd type="none" w="med" len="med"/>
+                    </a:lnB>
+                  </a:tcPr>
+                </a:tc>
+                <a:tc>
+                  <a:txBody>
+                    <a:bodyPr/>
+                    <a:lstStyle/>
+                    <a:p>
+                      <a:pPr indent="0" marL="0">
+                        <a:buNone/>
+                      </a:pPr>
+                      <a:r>
+                        <a:rPr lang="en-US" sz="1000" dirty="0">
+                          <a:solidFill>
+                            <a:srgbClr val="1E293B"/>
+                          </a:solidFill>
+                          <a:latin typeface="Inter" pitchFamily="34" charset="0"/>
+                          <a:ea typeface="Inter" pitchFamily="34" charset="-122"/>
+                          <a:cs typeface="Inter" pitchFamily="34" charset="-120"/>
+                        </a:rPr>
+                        <a:t>Tier 3 — Local 7B</a:t>
+                      </a:r>
+                      <a:endParaRPr lang="en-US" sz="1000" dirty="0">
+                        <a:latin typeface="Inter" charset="0"/>
+                        <a:ea typeface="Inter" charset="0"/>
+                        <a:cs typeface="Inter" charset="0"/>
+                      </a:endParaRPr>
+                    </a:p>
+                  </a:txBody>
+                  <a:tcPr marL="91440" marR="91440" marT="45720" marB="45720">
+                    <a:lnL w="6350" cap="flat" cmpd="sng" algn="ctr">
+                      <a:solidFill>
+                        <a:srgbClr val="E2E8F0"/>
+                      </a:solidFill>
+                      <a:prstDash val="solid"/>
+                      <a:round/>
+                      <a:headEnd type="none" w="med" len="med"/>
+                      <a:tailEnd type="none" w="med" len="med"/>
+                    </a:lnL>
+                    <a:lnR w="6350" cap="flat" cmpd="sng" algn="ctr">
+                      <a:solidFill>
+                        <a:srgbClr val="E2E8F0"/>
+                      </a:solidFill>
+                      <a:prstDash val="solid"/>
+                      <a:round/>
+                      <a:headEnd type="none" w="med" len="med"/>
+                      <a:tailEnd type="none" w="med" len="med"/>
+                    </a:lnR>
+                    <a:lnT w="6350" cap="flat" cmpd="sng" algn="ctr">
+                      <a:solidFill>
+                        <a:srgbClr val="E2E8F0"/>
+                      </a:solidFill>
+                      <a:prstDash val="solid"/>
+                      <a:round/>
+                      <a:headEnd type="none" w="med" len="med"/>
+                      <a:tailEnd type="none" w="med" len="med"/>
+                    </a:lnT>
+                    <a:lnB w="6350" cap="flat" cmpd="sng" algn="ctr">
+                      <a:solidFill>
+                        <a:srgbClr val="E2E8F0"/>
+                      </a:solidFill>
+                      <a:prstDash val="solid"/>
+                      <a:round/>
+                      <a:headEnd type="none" w="med" len="med"/>
+                      <a:tailEnd type="none" w="med" len="med"/>
+                    </a:lnB>
+                  </a:tcPr>
+                </a:tc>
+                <a:tc>
+                  <a:txBody>
+                    <a:bodyPr/>
+                    <a:lstStyle/>
+                    <a:p>
+                      <a:pPr indent="0" marL="0">
+                        <a:buNone/>
+                      </a:pPr>
+                      <a:r>
+                        <a:rPr lang="en-US" sz="1000" dirty="0">
+                          <a:solidFill>
+                            <a:srgbClr val="1E293B"/>
+                          </a:solidFill>
+                          <a:latin typeface="Inter" pitchFamily="34" charset="0"/>
+                          <a:ea typeface="Inter" pitchFamily="34" charset="-122"/>
+                          <a:cs typeface="Inter" pitchFamily="34" charset="-120"/>
+                        </a:rPr>
+                        <a:t>Qwen2.5-VL-7B | qwen2.5vl:7b | Ollama | 10 GB VRAM | 6.0 GB DL | Simplest setup</a:t>
+                      </a:r>
+                      <a:endParaRPr lang="en-US" sz="1000" dirty="0">
+                        <a:latin typeface="Inter" charset="0"/>
+                        <a:ea typeface="Inter" charset="0"/>
+                        <a:cs typeface="Inter" charset="0"/>
+                      </a:endParaRPr>
+                    </a:p>
+                  </a:txBody>
+                  <a:tcPr marL="91440" marR="91440" marT="45720" marB="45720">
+                    <a:lnL w="6350" cap="flat" cmpd="sng" algn="ctr">
+                      <a:solidFill>
+                        <a:srgbClr val="E2E8F0"/>
+                      </a:solidFill>
+                      <a:prstDash val="solid"/>
+                      <a:round/>
+                      <a:headEnd type="none" w="med" len="med"/>
+                      <a:tailEnd type="none" w="med" len="med"/>
+                    </a:lnL>
+                    <a:lnR w="6350" cap="flat" cmpd="sng" algn="ctr">
+                      <a:solidFill>
+                        <a:srgbClr val="E2E8F0"/>
+                      </a:solidFill>
+                      <a:prstDash val="solid"/>
+                      <a:round/>
+                      <a:headEnd type="none" w="med" len="med"/>
+                      <a:tailEnd type="none" w="med" len="med"/>
+                    </a:lnR>
+                    <a:lnT w="6350" cap="flat" cmpd="sng" algn="ctr">
+                      <a:solidFill>
+                        <a:srgbClr val="E2E8F0"/>
+                      </a:solidFill>
+                      <a:prstDash val="solid"/>
+                      <a:round/>
+                      <a:headEnd type="none" w="med" len="med"/>
+                      <a:tailEnd type="none" w="med" len="med"/>
+                    </a:lnT>
+                    <a:lnB w="6350" cap="flat" cmpd="sng" algn="ctr">
+                      <a:solidFill>
+                        <a:srgbClr val="E2E8F0"/>
+                      </a:solidFill>
+                      <a:prstDash val="solid"/>
+                      <a:round/>
+                      <a:headEnd type="none" w="med" len="med"/>
+                      <a:tailEnd type="none" w="med" len="med"/>
+                    </a:lnB>
+                  </a:tcPr>
+                </a:tc>
+              </a:tr>
+              <a:tr h="196427">
+                <a:tc>
+                  <a:txBody>
+                    <a:bodyPr/>
+                    <a:lstStyle/>
+                    <a:p>
+                      <a:pPr indent="0" marL="0">
+                        <a:buNone/>
+                      </a:pPr>
+                      <a:r>
+                        <a:rPr lang="en-US" sz="1000" dirty="0">
+                          <a:solidFill>
+                            <a:srgbClr val="1E293B"/>
+                          </a:solidFill>
+                          <a:latin typeface="Inter" pitchFamily="34" charset="0"/>
+                          <a:ea typeface="Inter" pitchFamily="34" charset="-122"/>
+                          <a:cs typeface="Inter" pitchFamily="34" charset="-120"/>
+                        </a:rPr>
+                        <a:t>AI Model</a:t>
+                      </a:r>
+                      <a:endParaRPr lang="en-US" sz="1000" dirty="0">
+                        <a:latin typeface="Inter" charset="0"/>
+                        <a:ea typeface="Inter" charset="0"/>
+                        <a:cs typeface="Inter" charset="0"/>
+                      </a:endParaRPr>
+                    </a:p>
+                  </a:txBody>
+                  <a:tcPr marL="91440" marR="91440" marT="45720" marB="45720">
+                    <a:lnL w="6350" cap="flat" cmpd="sng" algn="ctr">
+                      <a:solidFill>
+                        <a:srgbClr val="E2E8F0"/>
+                      </a:solidFill>
+                      <a:prstDash val="solid"/>
+                      <a:round/>
+                      <a:headEnd type="none" w="med" len="med"/>
+                      <a:tailEnd type="none" w="med" len="med"/>
+                    </a:lnL>
+                    <a:lnR w="6350" cap="flat" cmpd="sng" algn="ctr">
+                      <a:solidFill>
+                        <a:srgbClr val="E2E8F0"/>
+                      </a:solidFill>
+                      <a:prstDash val="solid"/>
+                      <a:round/>
+                      <a:headEnd type="none" w="med" len="med"/>
+                      <a:tailEnd type="none" w="med" len="med"/>
+                    </a:lnR>
+                    <a:lnT w="6350" cap="flat" cmpd="sng" algn="ctr">
+                      <a:solidFill>
+                        <a:srgbClr val="E2E8F0"/>
+                      </a:solidFill>
+                      <a:prstDash val="solid"/>
+                      <a:round/>
+                      <a:headEnd type="none" w="med" len="med"/>
+                      <a:tailEnd type="none" w="med" len="med"/>
+                    </a:lnT>
+                    <a:lnB w="6350" cap="flat" cmpd="sng" algn="ctr">
+                      <a:solidFill>
+                        <a:srgbClr val="E2E8F0"/>
+                      </a:solidFill>
+                      <a:prstDash val="solid"/>
+                      <a:round/>
+                      <a:headEnd type="none" w="med" len="med"/>
+                      <a:tailEnd type="none" w="med" len="med"/>
+                    </a:lnB>
+                  </a:tcPr>
+                </a:tc>
+                <a:tc>
+                  <a:txBody>
+                    <a:bodyPr/>
+                    <a:lstStyle/>
+                    <a:p>
+                      <a:pPr indent="0" marL="0">
+                        <a:buNone/>
+                      </a:pPr>
+                      <a:r>
+                        <a:rPr lang="en-US" sz="1000" dirty="0">
+                          <a:solidFill>
+                            <a:srgbClr val="1E293B"/>
+                          </a:solidFill>
+                          <a:latin typeface="Inter" pitchFamily="34" charset="0"/>
+                          <a:ea typeface="Inter" pitchFamily="34" charset="-122"/>
+                          <a:cs typeface="Inter" pitchFamily="34" charset="-120"/>
+                        </a:rPr>
+                        <a:t>Tier 4 — Datacenter</a:t>
+                      </a:r>
+                      <a:endParaRPr lang="en-US" sz="1000" dirty="0">
+                        <a:latin typeface="Inter" charset="0"/>
+                        <a:ea typeface="Inter" charset="0"/>
+                        <a:cs typeface="Inter" charset="0"/>
+                      </a:endParaRPr>
+                    </a:p>
+                  </a:txBody>
+                  <a:tcPr marL="91440" marR="91440" marT="45720" marB="45720">
+                    <a:lnL w="6350" cap="flat" cmpd="sng" algn="ctr">
+                      <a:solidFill>
+                        <a:srgbClr val="E2E8F0"/>
+                      </a:solidFill>
+                      <a:prstDash val="solid"/>
+                      <a:round/>
+                      <a:headEnd type="none" w="med" len="med"/>
+                      <a:tailEnd type="none" w="med" len="med"/>
+                    </a:lnL>
+                    <a:lnR w="6350" cap="flat" cmpd="sng" algn="ctr">
+                      <a:solidFill>
+                        <a:srgbClr val="E2E8F0"/>
+                      </a:solidFill>
+                      <a:prstDash val="solid"/>
+                      <a:round/>
+                      <a:headEnd type="none" w="med" len="med"/>
+                      <a:tailEnd type="none" w="med" len="med"/>
+                    </a:lnR>
+                    <a:lnT w="6350" cap="flat" cmpd="sng" algn="ctr">
+                      <a:solidFill>
+                        <a:srgbClr val="E2E8F0"/>
+                      </a:solidFill>
+                      <a:prstDash val="solid"/>
+                      <a:round/>
+                      <a:headEnd type="none" w="med" len="med"/>
+                      <a:tailEnd type="none" w="med" len="med"/>
+                    </a:lnT>
+                    <a:lnB w="6350" cap="flat" cmpd="sng" algn="ctr">
+                      <a:solidFill>
+                        <a:srgbClr val="E2E8F0"/>
+                      </a:solidFill>
+                      <a:prstDash val="solid"/>
+                      <a:round/>
+                      <a:headEnd type="none" w="med" len="med"/>
+                      <a:tailEnd type="none" w="med" len="med"/>
+                    </a:lnB>
+                  </a:tcPr>
+                </a:tc>
+                <a:tc>
+                  <a:txBody>
+                    <a:bodyPr/>
+                    <a:lstStyle/>
+                    <a:p>
+                      <a:pPr indent="0" marL="0">
+                        <a:buNone/>
+                      </a:pPr>
+                      <a:r>
+                        <a:rPr lang="en-US" sz="1000" dirty="0">
+                          <a:solidFill>
+                            <a:srgbClr val="1E293B"/>
+                          </a:solidFill>
+                          <a:latin typeface="Inter" pitchFamily="34" charset="0"/>
+                          <a:ea typeface="Inter" pitchFamily="34" charset="-122"/>
+                          <a:cs typeface="Inter" pitchFamily="34" charset="-120"/>
+                        </a:rPr>
+                        <a:t>Qwen2.5-VL-72B-AWQ | Qwen/Qwen2.5-VL-72B-Instruct-AWQ | vLLM | 48 GB VRAM | 41 GB DL | Multi-GPU regional</a:t>
+                      </a:r>
+                      <a:endParaRPr lang="en-US" sz="1000" dirty="0">
+                        <a:latin typeface="Inter" charset="0"/>
+                        <a:ea typeface="Inter" charset="0"/>
+                        <a:cs typeface="Inter" charset="0"/>
+                      </a:endParaRPr>
+                    </a:p>
+                  </a:txBody>
+                  <a:tcPr marL="91440" marR="91440" marT="45720" marB="45720">
+                    <a:lnL w="6350" cap="flat" cmpd="sng" algn="ctr">
+                      <a:solidFill>
+                        <a:srgbClr val="E2E8F0"/>
+                      </a:solidFill>
+                      <a:prstDash val="solid"/>
+                      <a:round/>
+                      <a:headEnd type="none" w="med" len="med"/>
+                      <a:tailEnd type="none" w="med" len="med"/>
+                    </a:lnL>
+                    <a:lnR w="6350" cap="flat" cmpd="sng" algn="ctr">
+                      <a:solidFill>
+                        <a:srgbClr val="E2E8F0"/>
+                      </a:solidFill>
+                      <a:prstDash val="solid"/>
+                      <a:round/>
+                      <a:headEnd type="none" w="med" len="med"/>
+                      <a:tailEnd type="none" w="med" len="med"/>
+                    </a:lnR>
+                    <a:lnT w="6350" cap="flat" cmpd="sng" algn="ctr">
+                      <a:solidFill>
+                        <a:srgbClr val="E2E8F0"/>
+                      </a:solidFill>
+                      <a:prstDash val="solid"/>
+                      <a:round/>
+                      <a:headEnd type="none" w="med" len="med"/>
+                      <a:tailEnd type="none" w="med" len="med"/>
+                    </a:lnT>
+                    <a:lnB w="6350" cap="flat" cmpd="sng" algn="ctr">
+                      <a:solidFill>
+                        <a:srgbClr val="E2E8F0"/>
+                      </a:solidFill>
+                      <a:prstDash val="solid"/>
+                      <a:round/>
+                      <a:headEnd type="none" w="med" len="med"/>
+                      <a:tailEnd type="none" w="med" len="med"/>
+                    </a:lnB>
+                  </a:tcPr>
+                </a:tc>
+              </a:tr>
+              <a:tr h="196427">
                 <a:tc>
                   <a:txBody>
                     <a:bodyPr/>
@@ -7125,7 +7913,7 @@
                   </a:tcPr>
                 </a:tc>
               </a:tr>
-              <a:tr h="230588">
+              <a:tr h="196427">
                 <a:tc>
                   <a:txBody>
                     <a:bodyPr/>
@@ -7322,7 +8110,7 @@
                   </a:tcPr>
                 </a:tc>
               </a:tr>
-              <a:tr h="230588">
+              <a:tr h="196427">
                 <a:tc>
                   <a:txBody>
                     <a:bodyPr/>
@@ -7519,7 +8307,7 @@
                   </a:tcPr>
                 </a:tc>
               </a:tr>
-              <a:tr h="230588">
+              <a:tr h="196427">
                 <a:tc>
                   <a:txBody>
                     <a:bodyPr/>
@@ -7716,7 +8504,7 @@
                   </a:tcPr>
                 </a:tc>
               </a:tr>
-              <a:tr h="230588">
+              <a:tr h="196427">
                 <a:tc>
                   <a:txBody>
                     <a:bodyPr/>
@@ -7913,7 +8701,7 @@
                   </a:tcPr>
                 </a:tc>
               </a:tr>
-              <a:tr h="230588">
+              <a:tr h="196427">
                 <a:tc>
                   <a:txBody>
                     <a:bodyPr/>
@@ -8110,7 +8898,7 @@
                   </a:tcPr>
                 </a:tc>
               </a:tr>
-              <a:tr h="230588">
+              <a:tr h="196427">
                 <a:tc>
                   <a:txBody>
                     <a:bodyPr/>
@@ -8307,7 +9095,7 @@
                   </a:tcPr>
                 </a:tc>
               </a:tr>
-              <a:tr h="230588">
+              <a:tr h="196427">
                 <a:tc>
                   <a:txBody>
                     <a:bodyPr/>
@@ -8504,7 +9292,7 @@
                   </a:tcPr>
                 </a:tc>
               </a:tr>
-              <a:tr h="230588">
+              <a:tr h="196427">
                 <a:tc>
                   <a:txBody>
                     <a:bodyPr/>
@@ -8701,7 +9489,7 @@
                   </a:tcPr>
                 </a:tc>
               </a:tr>
-              <a:tr h="230588">
+              <a:tr h="196427">
                 <a:tc>
                   <a:txBody>
                     <a:bodyPr/>
@@ -8898,7 +9686,7 @@
                   </a:tcPr>
                 </a:tc>
               </a:tr>
-              <a:tr h="230588">
+              <a:tr h="196427">
                 <a:tc>
                   <a:txBody>
                     <a:bodyPr/>

</xml_diff>